<commit_message>
Ajustar los textos de la presentación al estilo del autor
Co-Authored-By: Claude Sonnet 5.5 <noreply@anthropic.com>
Claude-Session: https://claude.ai/code/session_013aHpfjvs4B5gdaSHRxJk6F
</commit_message>
<xml_diff>
--- a/Actividad_Banco_ChristianPeralta.pptx
+++ b/Actividad_Banco_ChristianPeralta.pptx
@@ -2952,7 +2952,7 @@
       </p:sp>
       <p:pic>
         <p:nvPicPr>
-          <p:cNvPr id="4" name="Image 0" descr="CUENTA (saldo de la 101 tras un UPDATE previo)">    </p:cNvPr>
+          <p:cNvPr id="4" name="Image 0" descr="CUENTA (el saldo de la 101 ya viene de un UPDATE previo)">    </p:cNvPr>
           <p:cNvPicPr>
             <a:picLocks noChangeAspect="1"/>
           </p:cNvPicPr>
@@ -3007,7 +3007,7 @@
                 <a:ea typeface="Calibri" pitchFamily="34" charset="-122"/>
                 <a:cs typeface="Calibri" pitchFamily="34" charset="-120"/>
               </a:rPr>
-              <a:t>CUENTA (saldo de la 101 tras un UPDATE previo)</a:t>
+              <a:t>CUENTA (el saldo de la 101 ya viene de un UPDATE previo)</a:t>
             </a:r>
             <a:endParaRPr lang="en-US" sz="1200" dirty="0"/>
           </a:p>
@@ -3930,7 +3930,7 @@
       </p:sp>
       <p:pic>
         <p:nvPicPr>
-          <p:cNvPr id="4" name="Image 0" descr="1) Cada cliente con el nombre de su asesor (Elena Vega no tiene asesor y no aparece)">    </p:cNvPr>
+          <p:cNvPr id="4" name="Image 0" descr="1) Cada cliente con su asesor (Elena Vega no tiene asesor y por eso no sale)">    </p:cNvPr>
           <p:cNvPicPr>
             <a:picLocks noChangeAspect="1"/>
           </p:cNvPicPr>
@@ -3985,7 +3985,7 @@
                 <a:ea typeface="Calibri" pitchFamily="34" charset="-122"/>
                 <a:cs typeface="Calibri" pitchFamily="34" charset="-120"/>
               </a:rPr>
-              <a:t>1) Cada cliente con el nombre de su asesor (Elena Vega no tiene asesor y no aparece)</a:t>
+              <a:t>1) Cada cliente con su asesor (Elena Vega no tiene asesor y por eso no sale)</a:t>
             </a:r>
             <a:endParaRPr lang="en-US" sz="1200" dirty="0"/>
           </a:p>
@@ -4277,7 +4277,7 @@
       </p:sp>
       <p:pic>
         <p:nvPicPr>
-          <p:cNvPr id="6" name="Image 1" descr="4) Cada empleado con el nombre de su jefe (LEFT JOIN)">    </p:cNvPr>
+          <p:cNvPr id="6" name="Image 1" descr="4) Cada empleado con su jefe (LEFT JOIN)">    </p:cNvPr>
           <p:cNvPicPr>
             <a:picLocks noChangeAspect="1"/>
           </p:cNvPicPr>
@@ -4332,7 +4332,7 @@
                 <a:ea typeface="Calibri" pitchFamily="34" charset="-122"/>
                 <a:cs typeface="Calibri" pitchFamily="34" charset="-120"/>
               </a:rPr>
-              <a:t>4) Cada empleado con el nombre de su jefe (LEFT JOIN)</a:t>
+              <a:t>4) Cada empleado con su jefe (LEFT JOIN)</a:t>
             </a:r>
             <a:endParaRPr lang="en-US" sz="1200" dirty="0"/>
           </a:p>
@@ -4719,7 +4719,7 @@
       </p:sp>
       <p:pic>
         <p:nvPicPr>
-          <p:cNvPr id="4" name="Image 0" descr="Antes: saldo de la cuenta 101 = 2000.00">    </p:cNvPr>
+          <p:cNvPr id="4" name="Image 0" descr="Antes: el saldo de la cuenta 101 es 2000.00">    </p:cNvPr>
           <p:cNvPicPr>
             <a:picLocks noChangeAspect="1"/>
           </p:cNvPicPr>
@@ -4774,7 +4774,7 @@
                 <a:ea typeface="Calibri" pitchFamily="34" charset="-122"/>
                 <a:cs typeface="Calibri" pitchFamily="34" charset="-120"/>
               </a:rPr>
-              <a:t>Antes: saldo de la cuenta 101 = 2000.00</a:t>
+              <a:t>Antes: el saldo de la cuenta 101 es 2000.00</a:t>
             </a:r>
             <a:endParaRPr lang="en-US" sz="1200" dirty="0"/>
           </a:p>
@@ -4782,7 +4782,7 @@
       </p:sp>
       <p:pic>
         <p:nvPicPr>
-          <p:cNvPr id="6" name="Image 1" descr="UPDATE y después: saldo = 2500.00">    </p:cNvPr>
+          <p:cNvPr id="6" name="Image 1" descr="Hago el UPDATE y el saldo queda en 2500.00">    </p:cNvPr>
           <p:cNvPicPr>
             <a:picLocks noChangeAspect="1"/>
           </p:cNvPicPr>
@@ -4837,7 +4837,7 @@
                 <a:ea typeface="Calibri" pitchFamily="34" charset="-122"/>
                 <a:cs typeface="Calibri" pitchFamily="34" charset="-120"/>
               </a:rPr>
-              <a:t>UPDATE y después: saldo = 2500.00</a:t>
+              <a:t>Hago el UPDATE y el saldo queda en 2500.00</a:t>
             </a:r>
             <a:endParaRPr lang="en-US" sz="1200" dirty="0"/>
           </a:p>
@@ -5066,7 +5066,7 @@
       </p:sp>
       <p:pic>
         <p:nvPicPr>
-          <p:cNvPr id="6" name="Image 1" descr="DELETE del pago 2 del préstamo 1 y después: 3 filas">    </p:cNvPr>
+          <p:cNvPr id="6" name="Image 1" descr="Borro el pago 2 del préstamo 1 y quedan 3 filas">    </p:cNvPr>
           <p:cNvPicPr>
             <a:picLocks noChangeAspect="1"/>
           </p:cNvPicPr>
@@ -5121,7 +5121,7 @@
                 <a:ea typeface="Calibri" pitchFamily="34" charset="-122"/>
                 <a:cs typeface="Calibri" pitchFamily="34" charset="-120"/>
               </a:rPr>
-              <a:t>DELETE del pago 2 del préstamo 1 y después: 3 filas</a:t>
+              <a:t>Borro el pago 2 del préstamo 1 y quedan 3 filas</a:t>
             </a:r>
             <a:endParaRPr lang="en-US" sz="1200" dirty="0"/>
           </a:p>
@@ -5318,7 +5318,7 @@
                 <a:ea typeface="Calibri" pitchFamily="34" charset="-122"/>
                 <a:cs typeface="Calibri" pitchFamily="34" charset="-120"/>
               </a:rPr>
-              <a:t>Repositorio con los scripts completos:</a:t>
+              <a:t>Aquí dejé los scripts completos:</a:t>
             </a:r>
             <a:endParaRPr lang="en-US" sz="2000" dirty="0"/>
           </a:p>
@@ -5760,7 +5760,7 @@
                           <a:ea typeface="Calibri" pitchFamily="34" charset="-122"/>
                           <a:cs typeface="Calibri" pitchFamily="34" charset="-120"/>
                         </a:rPr>
-                        <a:t>Inserción de datos (INSERT), consultas (SELECT y JOIN), actualización (UPDATE) y borrado (DELETE)</a:t>
+                        <a:t>Datos (INSERT), consultas (SELECT y JOIN), actualización (UPDATE) y borrado (DELETE)</a:t>
                       </a:r>
                       <a:endParaRPr lang="en-US" sz="1500" dirty="0">
                         <a:latin typeface="Calibri" charset="0"/>
@@ -6050,7 +6050,7 @@
                 <a:ea typeface="Calibri" pitchFamily="34" charset="-122"/>
                 <a:cs typeface="Calibri" pitchFamily="34" charset="-120"/>
               </a:rPr>
-              <a:t>SQL es muy estricto: su manejo obliga a una arquitectura declarativa y fuertemente tipada, y limita la estructura de cualquier proyecto a las mismas bases. Primero se encuentran las entidades, se entienden las relaciones, se hace el diagrama relacional y solo después se construye todo.</a:t>
+              <a:t>SQL es demasiado estricto: el manejo del lenguaje obliga a usar una arquitectura declarativa y fuertemente tipada, y limita la estructura de cualquier proyecto a las mismas bases: primero encontrar las entidades, entender las relaciones, hacer el diagrama relacional y luego construirlo todo.</a:t>
             </a:r>
             <a:endParaRPr lang="en-US" sz="2000" dirty="0"/>
           </a:p>
@@ -6071,7 +6071,7 @@
                 <a:ea typeface="Calibri" pitchFamily="34" charset="-122"/>
                 <a:cs typeface="Calibri" pitchFamily="34" charset="-120"/>
               </a:rPr>
-              <a:t>Se evitó añadir correcciones al borrar registros. He observado que si borro, por ejemplo, un registro de una cuenta, MySQL no lo permite mientras existan datos relacionados en otras tablas, y tampoco los borra en cascada. Desconozco cómo conectar los borrados en cascada y, en vez de buscar cómo solucionarlo, lo dejo aquí como evidencia del avance y, a la vez, del desconocimiento sobre cómo conectar y dejar completamente funcional esta base de datos que presento.</a:t>
+              <a:t>Se evitó colocar correcciones al momento de borrar registros. He observado que si borro, por ejemplo, un registro de una cuenta, MySQL no me deja mientras existan datos relacionados en otras tablas, y tampoco los borra en cascada. Desconozco cómo conectarlo en cascada y, en vez de buscar cómo solucionarlo, lo dejo acá como evidencia del avance y, a la vez, de lo que desconozco sobre cómo conectar y dejar completamente funcional esta base de datos que estoy presentando.</a:t>
             </a:r>
             <a:endParaRPr lang="en-US" sz="2000" dirty="0"/>
           </a:p>
@@ -9959,7 +9959,7 @@
                 <a:ea typeface="Calibri" pitchFamily="34" charset="-122"/>
                 <a:cs typeface="Calibri" pitchFamily="34" charset="-120"/>
               </a:rPr>
-              <a:t>Las entidades débiles (Pago, Personas_A_Cargo) se identifican con la clave de su entidad propietaria más un discriminador (NumPago, Nombre). La antigüedad del empleado es un atributo derivado: no se almacena, se calcula a partir de la fecha de contratación.</a:t>
+              <a:t>Pago y Personas_A_Cargo son entidades débiles: no se pueden identificar solas, necesitan la clave del préstamo o del empleado más un dato propio (NumPago, Nombre). La antigüedad no la guardo, la calculo con la fecha de contratación.</a:t>
             </a:r>
             <a:endParaRPr lang="en-US" sz="1300" dirty="0"/>
           </a:p>
@@ -10784,7 +10784,7 @@
                           <a:ea typeface="Calibri" pitchFamily="34" charset="-122"/>
                           <a:cs typeface="Calibri" pitchFamily="34" charset="-120"/>
                         </a:rPr>
-                        <a:t>Un cliente tiene como mucho un asesor; un empleado asesora a varios clientes.</a:t>
+                        <a:t>Un cliente tiene como mucho un asesor; un empleado puede asesorar a varios clientes.</a:t>
                       </a:r>
                       <a:endParaRPr lang="en-US" sz="1300" dirty="0">
                         <a:latin typeface="Calibri" charset="0"/>
@@ -11126,7 +11126,7 @@
                           <a:ea typeface="Calibri" pitchFamily="34" charset="-122"/>
                           <a:cs typeface="Calibri" pitchFamily="34" charset="-120"/>
                         </a:rPr>
-                        <a:t>Relación reflexiva: el jefe también es empleado.</a:t>
+                        <a:t>Es una relación del empleado con él mismo: el jefe también es un empleado.</a:t>
                       </a:r>
                       <a:endParaRPr lang="en-US" sz="1300" dirty="0">
                         <a:latin typeface="Calibri" charset="0"/>
@@ -11468,7 +11468,7 @@
                           <a:ea typeface="Calibri" pitchFamily="34" charset="-122"/>
                           <a:cs typeface="Calibri" pitchFamily="34" charset="-120"/>
                         </a:rPr>
-                        <a:t>Atributo de la relación: FechaUltimoAcceso (depende del cliente y de la cuenta).</a:t>
+                        <a:t>Una cuenta puede tener varios titulares y un cliente varias cuentas. La fecha del último acceso va en la relación porque depende de los dos.</a:t>
                       </a:r>
                       <a:endParaRPr lang="en-US" sz="1300" dirty="0">
                         <a:latin typeface="Calibri" charset="0"/>
@@ -11810,7 +11810,7 @@
                           <a:ea typeface="Calibri" pitchFamily="34" charset="-122"/>
                           <a:cs typeface="Calibri" pitchFamily="34" charset="-120"/>
                         </a:rPr>
-                        <a:t>Un préstamo tiene uno o más titulares.</a:t>
+                        <a:t>Un préstamo tiene uno o más titulares y un cliente puede pedir varios préstamos.</a:t>
                       </a:r>
                       <a:endParaRPr lang="en-US" sz="1300" dirty="0">
                         <a:latin typeface="Calibri" charset="0"/>
@@ -12152,7 +12152,7 @@
                           <a:ea typeface="Calibri" pitchFamily="34" charset="-122"/>
                           <a:cs typeface="Calibri" pitchFamily="34" charset="-120"/>
                         </a:rPr>
-                        <a:t>Cada préstamo se ofrece desde una sucursal concreta.</a:t>
+                        <a:t>Cada préstamo sale de una sucursal concreta.</a:t>
                       </a:r>
                       <a:endParaRPr lang="en-US" sz="1300" dirty="0">
                         <a:latin typeface="Calibri" charset="0"/>
@@ -12494,7 +12494,7 @@
                           <a:ea typeface="Calibri" pitchFamily="34" charset="-122"/>
                           <a:cs typeface="Calibri" pitchFamily="34" charset="-120"/>
                         </a:rPr>
-                        <a:t>Dependencia de identificación: Pago es entidad débil.</a:t>
+                        <a:t>Pago es entidad débil: se identifica con el préstamo más su número de pago.</a:t>
                       </a:r>
                       <a:endParaRPr lang="en-US" sz="1300" dirty="0">
                         <a:latin typeface="Calibri" charset="0"/>
@@ -12836,7 +12836,7 @@
                           <a:ea typeface="Calibri" pitchFamily="34" charset="-122"/>
                           <a:cs typeface="Calibri" pitchFamily="34" charset="-120"/>
                         </a:rPr>
-                        <a:t>Dependencia de identificación: Personas_A_Cargo es entidad débil.</a:t>
+                        <a:t>Personas_A_Cargo es entidad débil: depende del empleado.</a:t>
                       </a:r>
                       <a:endParaRPr lang="en-US" sz="1300" dirty="0">
                         <a:latin typeface="Calibri" charset="0"/>
@@ -13178,7 +13178,7 @@
                           <a:ea typeface="Calibri" pitchFamily="34" charset="-122"/>
                           <a:cs typeface="Calibri" pitchFamily="34" charset="-120"/>
                         </a:rPr>
-                        <a:t>Especialización total y exclusiva: toda cuenta es de ahorro o corriente, nunca ambas.</a:t>
+                        <a:t>Toda cuenta es de ahorro o corriente, nunca las dos ni ninguna.</a:t>
                       </a:r>
                       <a:endParaRPr lang="en-US" sz="1300" dirty="0">
                         <a:latin typeface="Calibri" charset="0"/>
@@ -13267,7 +13267,7 @@
                 <a:ea typeface="Calibri" pitchFamily="34" charset="-122"/>
                 <a:cs typeface="Calibri" pitchFamily="34" charset="-120"/>
               </a:rPr>
-              <a:t>Cada par (mín,máx) indica cuántos elementos de la entidad hay por cada elemento de la entidad del otro extremo.</a:t>
+              <a:t>Leo cada (mín,máx) así: cuántos elementos hay de una entidad por cada elemento de la otra.</a:t>
             </a:r>
             <a:endParaRPr lang="en-US" sz="1300" dirty="0"/>
           </a:p>
@@ -13932,7 +13932,7 @@
                           <a:ea typeface="Calibri" pitchFamily="34" charset="-122"/>
                           <a:cs typeface="Calibri" pitchFamily="34" charset="-120"/>
                         </a:rPr>
-                        <a:t>Una tabla con su PK</a:t>
+                        <a:t>Una tabla con su clave primaria</a:t>
                       </a:r>
                       <a:endParaRPr lang="en-US" sz="1400" dirty="0">
                         <a:latin typeface="Calibri" charset="0"/>
@@ -14138,7 +14138,7 @@
                           <a:ea typeface="Calibri" pitchFamily="34" charset="-122"/>
                           <a:cs typeface="Calibri" pitchFamily="34" charset="-120"/>
                         </a:rPr>
-                        <a:t>La FK va en la tabla del lado N</a:t>
+                        <a:t>La clave foránea va en la tabla del lado N</a:t>
                       </a:r>
                       <a:endParaRPr lang="en-US" sz="1400" dirty="0">
                         <a:latin typeface="Calibri" charset="0"/>
@@ -14344,7 +14344,7 @@
                           <a:ea typeface="Calibri" pitchFamily="34" charset="-122"/>
                           <a:cs typeface="Calibri" pitchFamily="34" charset="-120"/>
                         </a:rPr>
-                        <a:t>Tabla intermedia con las dos claves como PK</a:t>
+                        <a:t>Una tabla intermedia con las dos claves</a:t>
                       </a:r>
                       <a:endParaRPr lang="en-US" sz="1400" dirty="0">
                         <a:latin typeface="Calibri" charset="0"/>
@@ -14550,7 +14550,7 @@
                           <a:ea typeface="Calibri" pitchFamily="34" charset="-122"/>
                           <a:cs typeface="Calibri" pitchFamily="34" charset="-120"/>
                         </a:rPr>
-                        <a:t>PK compuesta: clave del propietario + discriminador</a:t>
+                        <a:t>Clave compuesta: la del dueño más el dato propio</a:t>
                       </a:r>
                       <a:endParaRPr lang="en-US" sz="1400" dirty="0">
                         <a:latin typeface="Calibri" charset="0"/>
@@ -14756,7 +14756,7 @@
                           <a:ea typeface="Calibri" pitchFamily="34" charset="-122"/>
                           <a:cs typeface="Calibri" pitchFamily="34" charset="-120"/>
                         </a:rPr>
-                        <a:t>Una tabla por subtipo; su PK es a la vez FK a CUENTA</a:t>
+                        <a:t>Una tabla por tipo; su clave es también foránea hacia CUENTA</a:t>
                       </a:r>
                       <a:endParaRPr lang="en-US" sz="1400" dirty="0">
                         <a:latin typeface="Calibri" charset="0"/>
@@ -14962,7 +14962,7 @@
                           <a:ea typeface="Calibri" pitchFamily="34" charset="-122"/>
                           <a:cs typeface="Calibri" pitchFamily="34" charset="-120"/>
                         </a:rPr>
-                        <a:t>No se guarda; se calcula al consultar</a:t>
+                        <a:t>No lo guardo, lo calculo al consultar</a:t>
                       </a:r>
                       <a:endParaRPr lang="en-US" sz="1400" dirty="0">
                         <a:latin typeface="Calibri" charset="0"/>
@@ -15119,7 +15119,7 @@
                 <a:ea typeface="Calibri" pitchFamily="34" charset="-122"/>
                 <a:cs typeface="Calibri" pitchFamily="34" charset="-120"/>
               </a:rPr>
-              <a:t>Diferencias de nombre entre ambos diagramas: ID en PAGO = IdPrestamo, ID en CUENTA_CLIENTE = IdCliente, ID_P en PRESTAMO = IdPrestamo, FECHA en EMPLEADO = FechaContratacion, TASAS = TasaInteres. Son los mismos atributos con otro nombre; las 11 tablas coinciden con las 9 entidades y las 2 relaciones N:M.</a:t>
+              <a:t>Algunos nombres cambian entre el E/R y las tablas: ID en PAGO es IdPrestamo, ID en CUENTA_CLIENTE es IdCliente, ID_P en PRESTAMO es IdPrestamo, FECHA en EMPLEADO es FechaContratacion y TASAS es TasaInteres. Son los mismos atributos con otro nombre. Las 11 tablas salen de las 9 entidades y las 2 relaciones N:M.</a:t>
             </a:r>
             <a:endParaRPr lang="en-US" sz="1300" dirty="0"/>
           </a:p>
@@ -15340,7 +15340,7 @@
                 <a:ea typeface="Calibri" pitchFamily="34" charset="-122"/>
                 <a:cs typeface="Calibri" pitchFamily="34" charset="-120"/>
               </a:rPr>
-              <a:t>Salida de Workbench: CREATE DATABASE, USE y CREATE TABLE ejecutados sin errores (PERSONAS_A_CARGO, la última, se confirma en el SHOW TABLES)</a:t>
+              <a:t>Salida de Workbench: creé la base, usé banco y ejecuté los CREATE TABLE sin errores (la última, PERSONAS_A_CARGO, se ve en el SHOW TABLES)</a:t>
             </a:r>
             <a:endParaRPr lang="en-US" sz="1200" dirty="0"/>
           </a:p>
@@ -15403,7 +15403,7 @@
                 <a:ea typeface="Calibri" pitchFamily="34" charset="-122"/>
                 <a:cs typeface="Calibri" pitchFamily="34" charset="-120"/>
               </a:rPr>
-              <a:t>SHOW TABLES: las 11 tablas de la base «banco»</a:t>
+              <a:t>SHOW TABLES: las 11 tablas de la base banco</a:t>
             </a:r>
             <a:endParaRPr lang="en-US" sz="1200" dirty="0"/>
           </a:p>
@@ -15446,7 +15446,7 @@
                 <a:ea typeface="Calibri" pitchFamily="34" charset="-122"/>
                 <a:cs typeface="Calibri" pitchFamily="34" charset="-120"/>
               </a:rPr>
-              <a:t>Claves primarias y foráneas definidas con PRIMARY KEY y FOREIGN KEY.</a:t>
+              <a:t>Definí las claves primarias y foráneas con PRIMARY KEY y FOREIGN KEY.</a:t>
             </a:r>
             <a:endParaRPr lang="en-US" sz="1700" dirty="0"/>
           </a:p>
@@ -15467,7 +15467,7 @@
                 <a:ea typeface="Calibri" pitchFamily="34" charset="-122"/>
                 <a:cs typeface="Calibri" pitchFamily="34" charset="-120"/>
               </a:rPr>
-              <a:t>Las tablas se crean en orden: primero las que no dependen de otras.</a:t>
+              <a:t>Creé las tablas en orden: primero las que no dependen de otras.</a:t>
             </a:r>
             <a:endParaRPr lang="en-US" sz="1700" dirty="0"/>
           </a:p>
@@ -15488,7 +15488,7 @@
                 <a:ea typeface="Calibri" pitchFamily="34" charset="-122"/>
                 <a:cs typeface="Calibri" pitchFamily="34" charset="-120"/>
               </a:rPr>
-              <a:t>Sin borrado en cascada (ver conclusiones).</a:t>
+              <a:t>No usé borrado en cascada (lo explico en las conclusiones).</a:t>
             </a:r>
             <a:endParaRPr lang="en-US" sz="1700" dirty="0"/>
           </a:p>
@@ -15709,7 +15709,7 @@
                 <a:ea typeface="Calibri" pitchFamily="34" charset="-122"/>
                 <a:cs typeface="Calibri" pitchFamily="34" charset="-120"/>
               </a:rPr>
-              <a:t>Script de INSERT y salida de Workbench: inserciones ejecutadas sin advertencias (los SELECT siguientes comprueban las 11 tablas)</a:t>
+              <a:t>Script de INSERT y salida de Workbench: los INSERT se ejecutaron sin advertencias; los SELECT siguientes comprueban las 11 tablas</a:t>
             </a:r>
             <a:endParaRPr lang="en-US" sz="1200" dirty="0"/>
           </a:p>

</xml_diff>